<commit_message>
feat: Enlarge cover slide font sizes and add YouTube recommendation form to index
</commit_message>
<xml_diff>
--- a/docs/ai-era-designer-survival-strategy.pptx
+++ b/docs/ai-era-designer-survival-strategy.pptx
@@ -3108,7 +3108,7 @@
         </p:nvSpPr>
         <p:spPr>
           <a:xfrm>
-            <a:off x="914400" y="1097280"/>
+            <a:off x="914400" y="914400"/>
             <a:ext cx="10362895" cy="457200"/>
           </a:xfrm>
           <a:prstGeom prst="rect">
@@ -3123,7 +3123,7 @@
           <a:lstStyle/>
           <a:p>
             <a:pPr>
-              <a:defRPr sz="1600" b="1">
+              <a:defRPr sz="2200" b="1">
                 <a:solidFill>
                   <a:srgbClr val="FF6B6B"/>
                 </a:solidFill>
@@ -3144,7 +3144,7 @@
         </p:nvSpPr>
         <p:spPr>
           <a:xfrm>
-            <a:off x="914400" y="1645920"/>
+            <a:off x="914400" y="1463040"/>
             <a:ext cx="10362895" cy="1828800"/>
           </a:xfrm>
           <a:prstGeom prst="rect">
@@ -3159,7 +3159,7 @@
           <a:lstStyle/>
           <a:p>
             <a:pPr>
-              <a:defRPr sz="3600" b="1">
+              <a:defRPr sz="4600" b="1">
                 <a:solidFill>
                   <a:srgbClr val="FFFFFF"/>
                 </a:solidFill>
@@ -3180,8 +3180,8 @@
         </p:nvSpPr>
         <p:spPr>
           <a:xfrm>
-            <a:off x="914400" y="3474720"/>
-            <a:ext cx="2286000" cy="36576"/>
+            <a:off x="914400" y="3657600"/>
+            <a:ext cx="2286000" cy="54864"/>
           </a:xfrm>
           <a:prstGeom prst="rect">
             <a:avLst/>
@@ -3223,7 +3223,7 @@
         </p:nvSpPr>
         <p:spPr>
           <a:xfrm>
-            <a:off x="914400" y="3840480"/>
+            <a:off x="914400" y="4023360"/>
             <a:ext cx="10362895" cy="1828800"/>
           </a:xfrm>
           <a:prstGeom prst="rect">
@@ -3241,7 +3241,7 @@
               <a:lnSpc>
                 <a:spcPct val="130000"/>
               </a:lnSpc>
-              <a:defRPr sz="1800">
+              <a:defRPr sz="2400">
                 <a:solidFill>
                   <a:srgbClr val="A0A0B8"/>
                 </a:solidFill>

</xml_diff>